<commit_message>
Repository tidy-up for review: technical docs only
- docs/ARCHITECTURE.md: how the agent works (navigation, judge, scientific cycle, adaptation, LLM, decisions, tests)
- removed team rehearsal material (speech, pitch notes, Q&A prep, interim deck); speaker notes stripped from the deck
- README: document list and architecture updated for the scientific agent

Co-Authored-By: Claude Opus 5.5 <noreply@anthropic.com>
</commit_message>
<xml_diff>
--- a/docs/DID_Hack_IKA_Финал.pptx
+++ b/docs/DID_Hack_IKA_Финал.pptx
@@ -1570,13 +1570,7 @@
         <p:txBody>
           <a:bodyPr/>
           <a:lstStyle/>
-          <a:p>
-            <a:r>
-              <a:rPr lang="en-US" dirty="0"/>
-              <a:t>⏱ 10 с · Андрей. Мы команда IKA. Наш робот сам находит скрытые образцы, сам узнаёт, где пол дорогой, ведёт журнал гипотез и возвращается на базу. Справа - реальный прогон самого сложного сценария: семь из семи, без единой подсказки, где лежат образцы.</a:t>
-            </a:r>
-            <a:endParaRPr lang="en-US" dirty="0"/>
-          </a:p>
+          <a:p/>
         </p:txBody>
       </p:sp>
       <p:sp>
@@ -1658,13 +1652,7 @@
         <p:txBody>
           <a:bodyPr/>
           <a:lstStyle/>
-          <a:p>
-            <a:r>
-              <a:rPr lang="en-US" dirty="0"/>
-              <a:t>⏱ 25 с · Константин. Связь с идеей «ИИ как инфраструктура знаний». Агент не просто ездит - он производит знание: журнал гипотез с доказательствами и базу знаний, которую следующая миссия использует и перепроверяет. Мы это измерили: со знаниями прошлой миссии счёт выше, штрафов в два с половиной раза меньше. Применение: лаборатория, где робот сам ставит серию опытов и пишет протокол; учёба, где студент воспроизводит эксперимент по seed; полевые роботы, которые передают друг другу карту местности.</a:t>
-            </a:r>
-            <a:endParaRPr lang="en-US" dirty="0"/>
-          </a:p>
+          <a:p/>
         </p:txBody>
       </p:sp>
       <p:sp>
@@ -1746,13 +1734,7 @@
         <p:txBody>
           <a:bodyPr/>
           <a:lstStyle/>
-          <a:p>
-            <a:r>
-              <a:rPr lang="en-US" dirty="0"/>
-              <a:t>⏱ 10 с · Константин. Официальные пакеты ROS 2 и Gazebo, свой код на Python со 132 тестами, модель DeepSeek через ai.mai.ru, всё на ноутбуке без GPU. Разработку вели с Claude Code; повторяющиеся процедуры упаковали в три своих скилла.</a:t>
-            </a:r>
-            <a:endParaRPr lang="en-US" dirty="0"/>
-          </a:p>
+          <a:p/>
         </p:txBody>
       </p:sp>
       <p:sp>
@@ -1834,13 +1816,7 @@
         <p:txBody>
           <a:bodyPr/>
           <a:lstStyle/>
-          <a:p>
-            <a:r>
-              <a:rPr lang="en-US" dirty="0"/>
-              <a:t>⏱ 10 с · Константин. Все пять уровней сделаны и проверены. Дальше - SLAM, два робота с общей базой знаний и перенос на настоящий TurtleBot.</a:t>
-            </a:r>
-            <a:endParaRPr lang="en-US" dirty="0"/>
-          </a:p>
+          <a:p/>
         </p:txBody>
       </p:sp>
       <p:sp>
@@ -1922,13 +1898,7 @@
         <p:txBody>
           <a:bodyPr/>
           <a:lstStyle/>
-          <a:p>
-            <a:r>
-              <a:rPr lang="en-US" dirty="0"/>
-              <a:t>⏱ 5 с. Спасибо! Ниже - слайды-приложения для ответов на вопросы.</a:t>
-            </a:r>
-            <a:endParaRPr lang="en-US" dirty="0"/>
-          </a:p>
+          <a:p/>
         </p:txBody>
       </p:sp>
       <p:sp>
@@ -2010,13 +1980,7 @@
         <p:txBody>
           <a:bodyPr/>
           <a:lstStyle/>
-          <a:p>
-            <a:r>
-              <a:rPr lang="en-US" dirty="0"/>
-              <a:t>Если спросят про методику и цифры экспериментов.</a:t>
-            </a:r>
-            <a:endParaRPr lang="en-US" dirty="0"/>
-          </a:p>
+          <a:p/>
         </p:txBody>
       </p:sp>
       <p:sp>
@@ -2098,13 +2062,7 @@
         <p:txBody>
           <a:bodyPr/>
           <a:lstStyle/>
-          <a:p>
-            <a:r>
-              <a:rPr lang="en-US" dirty="0"/>
-              <a:t>Если спросят «почему модель не управляет всем сама». Эксперименты с шестью моделями ai.mai.ru и пример ответа советника.</a:t>
-            </a:r>
-            <a:endParaRPr lang="en-US" dirty="0"/>
-          </a:p>
+          <a:p/>
         </p:txBody>
       </p:sp>
       <p:sp>
@@ -2186,13 +2144,7 @@
         <p:txBody>
           <a:bodyPr/>
           <a:lstStyle/>
-          <a:p>
-            <a:r>
-              <a:rPr lang="en-US" dirty="0"/>
-              <a:t>Если спросят «как вы использовали ИИ». Цикл разработки, что нашёл ассистент, три скилла в .claude/skills, что решали люди.</a:t>
-            </a:r>
-            <a:endParaRPr lang="en-US" dirty="0"/>
-          </a:p>
+          <a:p/>
         </p:txBody>
       </p:sp>
       <p:sp>
@@ -2274,13 +2226,7 @@
         <p:txBody>
           <a:bodyPr/>
           <a:lstStyle/>
-          <a:p>
-            <a:r>
-              <a:rPr lang="en-US" dirty="0"/>
-              <a:t>⏱ 15 с · Андрей. Агент не знает, где образцы и где дорогой пол, - у него есть только датчик близости и батарея. В сложном сценарии среда ещё и меняется без предупреждения. Цель - агент, который сам замыкает научный цикл: гипотеза, действие, данные, вывод.</a:t>
-            </a:r>
-            <a:endParaRPr lang="en-US" dirty="0"/>
-          </a:p>
+          <a:p/>
         </p:txBody>
       </p:sp>
       <p:sp>
@@ -2362,13 +2308,7 @@
         <p:txBody>
           <a:bodyPr/>
           <a:lstStyle/>
-          <a:p>
-            <a:r>
-              <a:rPr lang="en-US" dirty="0"/>
-              <a:t>⏱ 30 с · Андрей. Любую задачу можно записать как функцию. Агент - функция F: на входе карта, образцы и заряд, на выходе маршрут, который максимизирует оценку J: 10 за образец, минус штрафы, плюс 0,1 за оставшийся заряд при возврате. Ниже формулы поведения: заряд убывает с путём и быстрее на дорогом грунте, цена переезда - путь A* на измеренный расход, ограничения, модель датчика, правило перепланирования. Справа - оптимум, если бы всё было известно; наш агент образцов не знает и исследует, поэтому оптимум - верхняя граница. Метрики - это слагаемые этой функции.</a:t>
-            </a:r>
-            <a:endParaRPr lang="en-US" dirty="0"/>
-          </a:p>
+          <a:p/>
         </p:txBody>
       </p:sp>
       <p:sp>
@@ -2450,13 +2390,7 @@
         <p:txBody>
           <a:bodyPr/>
           <a:lstStyle/>
-          <a:p>
-            <a:r>
-              <a:rPr lang="en-US" dirty="0"/>
-              <a:t>⏱ 30 с · Андрей. Мы сформулировали три гипотезы и проверили каждую парным экспериментом на тысячах миссий. H1 - что изучение цены пола само по себе даёт больше образцов - статистически не подтвердилась: на лёгких уровнях плюс, на сложном нет, потому что про зону агент узнаёт, только когда её уже проехал. Отсюда родилась H2: переносить знания между миссиями. Она подтвердилась: счёт выше, штрафов в сложном сценарии в два с половиной раза меньше. H3 про LLM - частично: образцов столько же, а штрафов вдвое меньше.</a:t>
-            </a:r>
-            <a:endParaRPr lang="en-US" dirty="0"/>
-          </a:p>
+          <a:p/>
         </p:txBody>
       </p:sp>
       <p:sp>
@@ -2538,13 +2472,7 @@
         <p:txBody>
           <a:bodyPr/>
           <a:lstStyle/>
-          <a:p>
-            <a:r>
-              <a:rPr lang="en-US" dirty="0"/>
-              <a:t>⏱ 20 с · Илья. Это настоящий прогон сложного сценария в Gazebo через наш пульт. Слева через 36 секунд: фиолетовым - где агент ещё не искал, кольцо - его текущая гипотеза о положении образца. В центре финал: семь из семи, оранжевые клетки - дорогой пол, который агент нашёл по расходу батареи. Справа - журнал: гипотезы со статусами, включая сбой датчика, который агент распознал сам.</a:t>
-            </a:r>
-            <a:endParaRPr lang="en-US" dirty="0"/>
-          </a:p>
+          <a:p/>
         </p:txBody>
       </p:sp>
       <p:sp>
@@ -2626,13 +2554,7 @@
         <p:txBody>
           <a:bodyPr/>
           <a:lstStyle/>
-          <a:p>
-            <a:r>
-              <a:rPr lang="en-US" dirty="0"/>
-              <a:t>⏱ 20 с · Илья. В центре - наш агент: научный планировщик с журналом, A*, регулятор, локализация. Он получает с робота колёса, гироскоп и лидар, от судьи - батарею, датчик образцов и штрафы. Что знает агент: стены и базу знаний прошлых миссий, которую сам и пишет. В ключевые моменты он отправляет журнал и варианты языковой модели, она выбирает стратегию. Судья - отдельный узел: сценарии, батарея, очки.</a:t>
-            </a:r>
-            <a:endParaRPr lang="en-US" dirty="0"/>
-          </a:p>
+          <a:p/>
         </p:txBody>
       </p:sp>
       <p:sp>
@@ -2714,13 +2636,7 @@
         <p:txBody>
           <a:bodyPr/>
           <a:lstStyle/>
-          <a:p>
-            <a:r>
-              <a:rPr lang="en-US" dirty="0"/>
-              <a:t>⏱ 15 с · Илья. От карты до колёс: карта стоимостей - стены плюс то, что агент выучил о грунтах и опасностях, A* за 10 миллисекунд, регулятор и лидар. Положение: путь из колёс, курс из гироскопа - ошибка у образца упала с 28 до 5 сантиметров. [Затем - живое демо, ~1 мин.]</a:t>
-            </a:r>
-            <a:endParaRPr lang="en-US" dirty="0"/>
-          </a:p>
+          <a:p/>
         </p:txBody>
       </p:sp>
       <p:sp>
@@ -2802,13 +2718,7 @@
         <p:txBody>
           <a:bodyPr/>
           <a:lstStyle/>
-          <a:p>
-            <a:r>
-              <a:rPr lang="en-US" dirty="0"/>
-              <a:t>⏱ 30 с · Константин. Агент крутит научный цикл. Гипотеза: например, «образец около этой точки» или «этот участок вдвое дороже». Действие: подъехать и измерить. Данные: датчик работает как дальномер, батарея - как измеритель цены пола. Вывод: гипотеза подтверждена, опровергнута или среда изменилась - и карта обновляется. Если расход ушёл из прогноза, вырос шум датчика или пришёл штраф - это новая гипотеза и новый маршрут. Робота ведёт алгоритм. Языковая модель - научный руководитель: в ключевые моменты читает журнал, выбирает, где искать дальше или пора домой, и объясняет почему. Каждый её ответ проверяет код, а робот не стоит в ожидании.</a:t>
-            </a:r>
-            <a:endParaRPr lang="en-US" dirty="0"/>
-          </a:p>
+          <a:p/>
         </p:txBody>
       </p:sp>
       <p:sp>
@@ -2890,13 +2800,7 @@
         <p:txBody>
           <a:bodyPr/>
           <a:lstStyle/>
-          <a:p>
-            <a:r>
-              <a:rPr lang="en-US" dirty="0"/>
-              <a:t>⏱ 25 с · Константин. В Gazebo научный агент без единой подсказки собрал семь из семи в самом сложном сценарии, без штрафов, и сам распознал сбой датчика. Офлайн 360 миссий из 360 вернулись на базу. С базой знаний в сложном сценарии штрафов 8 вместо 20 и счёт выше. Языковая модель ответила корректно 121 раз из 121.</a:t>
-            </a:r>
-            <a:endParaRPr lang="en-US" dirty="0"/>
-          </a:p>
+          <a:p/>
         </p:txBody>
       </p:sp>
       <p:sp>

</xml_diff>